<commit_message>
Add author name (Aparna Jha) to business proposal title and closing slides
Co-Authored-By: Claude Opus 4.8 <noreply@anthropic.com>
</commit_message>
<xml_diff>
--- a/proposal/CLEARANCE-Business-Proposal.pptx
+++ b/proposal/CLEARANCE-Business-Proposal.pptx
@@ -2460,7 +2460,7 @@
         </p:nvSpPr>
         <p:spPr>
           <a:xfrm>
-            <a:off x="548640" y="5806440"/>
+            <a:off x="548640" y="5742432"/>
             <a:ext cx="5486400" cy="365760"/>
           </a:xfrm>
           <a:prstGeom prst="rect">
@@ -2499,19 +2499,33 @@
         </p:nvSpPr>
         <p:spPr>
           <a:xfrm>
-            <a:off x="548640" y="6144768"/>
-            <a:ext cx="10058400" cy="320040"/>
-          </a:xfrm>
-          <a:prstGeom prst="rect">
-            <a:avLst/>
-          </a:prstGeom>
-          <a:noFill/>
-          <a:ln/>
-        </p:spPr>
-        <p:txBody>
-          <a:bodyPr wrap="square" lIns="0" tIns="0" rIns="0" bIns="0" rtlCol="0" anchor="ctr"/>
-          <a:lstStyle/>
-          <a:p>
+            <a:off x="548640" y="6089904"/>
+            <a:ext cx="10972800" cy="320040"/>
+          </a:xfrm>
+          <a:prstGeom prst="rect">
+            <a:avLst/>
+          </a:prstGeom>
+          <a:noFill/>
+          <a:ln/>
+        </p:spPr>
+        <p:txBody>
+          <a:bodyPr wrap="square" lIns="0" tIns="0" rIns="0" bIns="0" rtlCol="0" anchor="ctr"/>
+          <a:lstStyle/>
+          <a:p>
+            <a:pPr indent="0" marL="0">
+              <a:buNone/>
+            </a:pPr>
+            <a:r>
+              <a:rPr lang="en-US" sz="1200" b="1" dirty="0">
+                <a:solidFill>
+                  <a:srgbClr val="FFFFFF"/>
+                </a:solidFill>
+                <a:latin typeface="Calibri" pitchFamily="34" charset="0"/>
+                <a:ea typeface="Calibri" pitchFamily="34" charset="-122"/>
+                <a:cs typeface="Calibri" pitchFamily="34" charset="-120"/>
+              </a:rPr>
+              <a:t>Aparna Jha</a:t>
+            </a:r>
             <a:pPr indent="0" marL="0">
               <a:buNone/>
             </a:pPr>
@@ -2524,7 +2538,7 @@
                 <a:ea typeface="Calibri" pitchFamily="34" charset="-122"/>
                 <a:cs typeface="Calibri" pitchFamily="34" charset="-120"/>
               </a:rPr>
-              <a:t>Accenture Innovation Challenge 2026  ·  Round 2  ·  Track 1 (ControlPlane.ai)</a:t>
+              <a:t>   ·   Accenture Innovation Challenge 2026  ·  Round 2  ·  Track 1 (ControlPlane.ai)</a:t>
             </a:r>
             <a:endParaRPr lang="en-US" sz="1200" dirty="0"/>
           </a:p>
@@ -6259,7 +6273,7 @@
         </p:nvSpPr>
         <p:spPr>
           <a:xfrm>
-            <a:off x="548640" y="5806440"/>
+            <a:off x="548640" y="5742432"/>
             <a:ext cx="8229600" cy="365760"/>
           </a:xfrm>
           <a:prstGeom prst="rect">
@@ -6298,19 +6312,33 @@
         </p:nvSpPr>
         <p:spPr>
           <a:xfrm>
-            <a:off x="548640" y="6172200"/>
-            <a:ext cx="8229600" cy="274320"/>
-          </a:xfrm>
-          <a:prstGeom prst="rect">
-            <a:avLst/>
-          </a:prstGeom>
-          <a:noFill/>
-          <a:ln/>
-        </p:spPr>
-        <p:txBody>
-          <a:bodyPr wrap="square" lIns="0" tIns="0" rIns="0" bIns="0" rtlCol="0" anchor="ctr"/>
-          <a:lstStyle/>
-          <a:p>
+            <a:off x="548640" y="6108192"/>
+            <a:ext cx="9144000" cy="274320"/>
+          </a:xfrm>
+          <a:prstGeom prst="rect">
+            <a:avLst/>
+          </a:prstGeom>
+          <a:noFill/>
+          <a:ln/>
+        </p:spPr>
+        <p:txBody>
+          <a:bodyPr wrap="square" lIns="0" tIns="0" rIns="0" bIns="0" rtlCol="0" anchor="ctr"/>
+          <a:lstStyle/>
+          <a:p>
+            <a:pPr indent="0" marL="0">
+              <a:buNone/>
+            </a:pPr>
+            <a:r>
+              <a:rPr lang="en-US" sz="1100" b="1" dirty="0">
+                <a:solidFill>
+                  <a:srgbClr val="5EB0FF"/>
+                </a:solidFill>
+                <a:latin typeface="Calibri" pitchFamily="34" charset="0"/>
+                <a:ea typeface="Calibri" pitchFamily="34" charset="-122"/>
+                <a:cs typeface="Calibri" pitchFamily="34" charset="-120"/>
+              </a:rPr>
+              <a:t>Aparna Jha</a:t>
+            </a:r>
             <a:pPr indent="0" marL="0">
               <a:buNone/>
             </a:pPr>
@@ -6323,7 +6351,7 @@
                 <a:ea typeface="Calibri" pitchFamily="34" charset="-122"/>
                 <a:cs typeface="Calibri" pitchFamily="34" charset="-120"/>
               </a:rPr>
-              <a:t>Accenture Innovation Challenge 2026 · Round 2 · Track 1</a:t>
+              <a:t>   ·   Accenture Innovation Challenge 2026 · Round 2 · Track 1</a:t>
             </a:r>
             <a:endParaRPr lang="en-US" sz="1100" dirty="0"/>
           </a:p>

</xml_diff>